<commit_message>
Update binary presentation files in part1 HTML:CSS:JavaScript directory
</commit_message>
<xml_diff>
--- a/课件/part1.HTML:CSS:JavaScript/第0章续-Web应用基础设施.pptx
+++ b/课件/part1.HTML:CSS:JavaScript/第0章续-Web应用基础设施.pptx
@@ -4127,7 +4127,7 @@
           <a:p>
             <a:fld id="{041058C9-5BED-3E43-979B-AFDC4787B12B}" type="datetimeFigureOut">
               <a:rPr kumimoji="1" lang="zh-CN" altLang="en-US" smtClean="0"/>
-              <a:t>2024/3/1</a:t>
+              <a:t>2026/3/1</a:t>
             </a:fld>
             <a:endParaRPr kumimoji="1" lang="zh-CN" altLang="en-US"/>
           </a:p>
@@ -5193,7 +5193,7 @@
           <a:p>
             <a:fld id="{0106EFE4-10E4-3C4A-871D-F8DF725B069F}" type="datetimeFigureOut">
               <a:rPr kumimoji="1" lang="zh-CN" altLang="en-US" smtClean="0"/>
-              <a:t>2024/3/1</a:t>
+              <a:t>2026/3/1</a:t>
             </a:fld>
             <a:endParaRPr kumimoji="1" lang="zh-CN" altLang="en-US"/>
           </a:p>
@@ -5391,7 +5391,7 @@
           <a:p>
             <a:fld id="{0106EFE4-10E4-3C4A-871D-F8DF725B069F}" type="datetimeFigureOut">
               <a:rPr kumimoji="1" lang="zh-CN" altLang="en-US" smtClean="0"/>
-              <a:t>2024/3/1</a:t>
+              <a:t>2026/3/1</a:t>
             </a:fld>
             <a:endParaRPr kumimoji="1" lang="zh-CN" altLang="en-US"/>
           </a:p>
@@ -5599,7 +5599,7 @@
           <a:p>
             <a:fld id="{0106EFE4-10E4-3C4A-871D-F8DF725B069F}" type="datetimeFigureOut">
               <a:rPr kumimoji="1" lang="zh-CN" altLang="en-US" smtClean="0"/>
-              <a:t>2024/3/1</a:t>
+              <a:t>2026/3/1</a:t>
             </a:fld>
             <a:endParaRPr kumimoji="1" lang="zh-CN" altLang="en-US"/>
           </a:p>
@@ -5797,7 +5797,7 @@
           <a:p>
             <a:fld id="{0106EFE4-10E4-3C4A-871D-F8DF725B069F}" type="datetimeFigureOut">
               <a:rPr kumimoji="1" lang="zh-CN" altLang="en-US" smtClean="0"/>
-              <a:t>2024/3/1</a:t>
+              <a:t>2026/3/1</a:t>
             </a:fld>
             <a:endParaRPr kumimoji="1" lang="zh-CN" altLang="en-US"/>
           </a:p>
@@ -6072,7 +6072,7 @@
           <a:p>
             <a:fld id="{0106EFE4-10E4-3C4A-871D-F8DF725B069F}" type="datetimeFigureOut">
               <a:rPr kumimoji="1" lang="zh-CN" altLang="en-US" smtClean="0"/>
-              <a:t>2024/3/1</a:t>
+              <a:t>2026/3/1</a:t>
             </a:fld>
             <a:endParaRPr kumimoji="1" lang="zh-CN" altLang="en-US"/>
           </a:p>
@@ -6337,7 +6337,7 @@
           <a:p>
             <a:fld id="{0106EFE4-10E4-3C4A-871D-F8DF725B069F}" type="datetimeFigureOut">
               <a:rPr kumimoji="1" lang="zh-CN" altLang="en-US" smtClean="0"/>
-              <a:t>2024/3/1</a:t>
+              <a:t>2026/3/1</a:t>
             </a:fld>
             <a:endParaRPr kumimoji="1" lang="zh-CN" altLang="en-US"/>
           </a:p>
@@ -6749,7 +6749,7 @@
           <a:p>
             <a:fld id="{0106EFE4-10E4-3C4A-871D-F8DF725B069F}" type="datetimeFigureOut">
               <a:rPr kumimoji="1" lang="zh-CN" altLang="en-US" smtClean="0"/>
-              <a:t>2024/3/1</a:t>
+              <a:t>2026/3/1</a:t>
             </a:fld>
             <a:endParaRPr kumimoji="1" lang="zh-CN" altLang="en-US"/>
           </a:p>
@@ -6890,7 +6890,7 @@
           <a:p>
             <a:fld id="{0106EFE4-10E4-3C4A-871D-F8DF725B069F}" type="datetimeFigureOut">
               <a:rPr kumimoji="1" lang="zh-CN" altLang="en-US" smtClean="0"/>
-              <a:t>2024/3/1</a:t>
+              <a:t>2026/3/1</a:t>
             </a:fld>
             <a:endParaRPr kumimoji="1" lang="zh-CN" altLang="en-US"/>
           </a:p>
@@ -7003,7 +7003,7 @@
           <a:p>
             <a:fld id="{0106EFE4-10E4-3C4A-871D-F8DF725B069F}" type="datetimeFigureOut">
               <a:rPr kumimoji="1" lang="zh-CN" altLang="en-US" smtClean="0"/>
-              <a:t>2024/3/1</a:t>
+              <a:t>2026/3/1</a:t>
             </a:fld>
             <a:endParaRPr kumimoji="1" lang="zh-CN" altLang="en-US"/>
           </a:p>
@@ -7314,7 +7314,7 @@
           <a:p>
             <a:fld id="{0106EFE4-10E4-3C4A-871D-F8DF725B069F}" type="datetimeFigureOut">
               <a:rPr kumimoji="1" lang="zh-CN" altLang="en-US" smtClean="0"/>
-              <a:t>2024/3/1</a:t>
+              <a:t>2026/3/1</a:t>
             </a:fld>
             <a:endParaRPr kumimoji="1" lang="zh-CN" altLang="en-US"/>
           </a:p>
@@ -7602,7 +7602,7 @@
           <a:p>
             <a:fld id="{0106EFE4-10E4-3C4A-871D-F8DF725B069F}" type="datetimeFigureOut">
               <a:rPr kumimoji="1" lang="zh-CN" altLang="en-US" smtClean="0"/>
-              <a:t>2024/3/1</a:t>
+              <a:t>2026/3/1</a:t>
             </a:fld>
             <a:endParaRPr kumimoji="1" lang="zh-CN" altLang="en-US"/>
           </a:p>
@@ -7843,7 +7843,7 @@
           <a:p>
             <a:fld id="{0106EFE4-10E4-3C4A-871D-F8DF725B069F}" type="datetimeFigureOut">
               <a:rPr kumimoji="1" lang="zh-CN" altLang="en-US" smtClean="0"/>
-              <a:t>2024/3/1</a:t>
+              <a:t>2026/3/1</a:t>
             </a:fld>
             <a:endParaRPr kumimoji="1" lang="zh-CN" altLang="en-US"/>
           </a:p>
@@ -9725,68 +9725,68 @@
           <a:custGeom>
             <a:avLst/>
             <a:gdLst>
-              <a:gd name="connsiteX0" fmla="*/ 0 w 3255095"/>
-              <a:gd name="connsiteY0" fmla="*/ 0 h 18288"/>
-              <a:gd name="connsiteX1" fmla="*/ 618468 w 3255095"/>
-              <a:gd name="connsiteY1" fmla="*/ 0 h 18288"/>
-              <a:gd name="connsiteX2" fmla="*/ 1269487 w 3255095"/>
-              <a:gd name="connsiteY2" fmla="*/ 0 h 18288"/>
-              <a:gd name="connsiteX3" fmla="*/ 1953057 w 3255095"/>
-              <a:gd name="connsiteY3" fmla="*/ 0 h 18288"/>
-              <a:gd name="connsiteX4" fmla="*/ 2636627 w 3255095"/>
-              <a:gd name="connsiteY4" fmla="*/ 0 h 18288"/>
-              <a:gd name="connsiteX5" fmla="*/ 3255095 w 3255095"/>
-              <a:gd name="connsiteY5" fmla="*/ 0 h 18288"/>
-              <a:gd name="connsiteX6" fmla="*/ 3255095 w 3255095"/>
-              <a:gd name="connsiteY6" fmla="*/ 18288 h 18288"/>
-              <a:gd name="connsiteX7" fmla="*/ 2538974 w 3255095"/>
-              <a:gd name="connsiteY7" fmla="*/ 18288 h 18288"/>
-              <a:gd name="connsiteX8" fmla="*/ 1822853 w 3255095"/>
-              <a:gd name="connsiteY8" fmla="*/ 18288 h 18288"/>
-              <a:gd name="connsiteX9" fmla="*/ 1171834 w 3255095"/>
-              <a:gd name="connsiteY9" fmla="*/ 18288 h 18288"/>
-              <a:gd name="connsiteX10" fmla="*/ 0 w 3255095"/>
-              <a:gd name="connsiteY10" fmla="*/ 18288 h 18288"/>
-              <a:gd name="connsiteX11" fmla="*/ 0 w 3255095"/>
-              <a:gd name="connsiteY11" fmla="*/ 0 h 18288"/>
+              <a:gd name="csX0" fmla="*/ 0 w 3255095"/>
+              <a:gd name="csY0" fmla="*/ 0 h 18288"/>
+              <a:gd name="csX1" fmla="*/ 618468 w 3255095"/>
+              <a:gd name="csY1" fmla="*/ 0 h 18288"/>
+              <a:gd name="csX2" fmla="*/ 1269487 w 3255095"/>
+              <a:gd name="csY2" fmla="*/ 0 h 18288"/>
+              <a:gd name="csX3" fmla="*/ 1953057 w 3255095"/>
+              <a:gd name="csY3" fmla="*/ 0 h 18288"/>
+              <a:gd name="csX4" fmla="*/ 2636627 w 3255095"/>
+              <a:gd name="csY4" fmla="*/ 0 h 18288"/>
+              <a:gd name="csX5" fmla="*/ 3255095 w 3255095"/>
+              <a:gd name="csY5" fmla="*/ 0 h 18288"/>
+              <a:gd name="csX6" fmla="*/ 3255095 w 3255095"/>
+              <a:gd name="csY6" fmla="*/ 18288 h 18288"/>
+              <a:gd name="csX7" fmla="*/ 2538974 w 3255095"/>
+              <a:gd name="csY7" fmla="*/ 18288 h 18288"/>
+              <a:gd name="csX8" fmla="*/ 1822853 w 3255095"/>
+              <a:gd name="csY8" fmla="*/ 18288 h 18288"/>
+              <a:gd name="csX9" fmla="*/ 1171834 w 3255095"/>
+              <a:gd name="csY9" fmla="*/ 18288 h 18288"/>
+              <a:gd name="csX10" fmla="*/ 0 w 3255095"/>
+              <a:gd name="csY10" fmla="*/ 18288 h 18288"/>
+              <a:gd name="csX11" fmla="*/ 0 w 3255095"/>
+              <a:gd name="csY11" fmla="*/ 0 h 18288"/>
             </a:gdLst>
             <a:ahLst/>
             <a:cxnLst>
               <a:cxn ang="0">
-                <a:pos x="connsiteX0" y="connsiteY0"/>
+                <a:pos x="csX0" y="csY0"/>
               </a:cxn>
               <a:cxn ang="0">
-                <a:pos x="connsiteX1" y="connsiteY1"/>
+                <a:pos x="csX1" y="csY1"/>
               </a:cxn>
               <a:cxn ang="0">
-                <a:pos x="connsiteX2" y="connsiteY2"/>
+                <a:pos x="csX2" y="csY2"/>
               </a:cxn>
               <a:cxn ang="0">
-                <a:pos x="connsiteX3" y="connsiteY3"/>
+                <a:pos x="csX3" y="csY3"/>
               </a:cxn>
               <a:cxn ang="0">
-                <a:pos x="connsiteX4" y="connsiteY4"/>
+                <a:pos x="csX4" y="csY4"/>
               </a:cxn>
               <a:cxn ang="0">
-                <a:pos x="connsiteX5" y="connsiteY5"/>
+                <a:pos x="csX5" y="csY5"/>
               </a:cxn>
               <a:cxn ang="0">
-                <a:pos x="connsiteX6" y="connsiteY6"/>
+                <a:pos x="csX6" y="csY6"/>
               </a:cxn>
               <a:cxn ang="0">
-                <a:pos x="connsiteX7" y="connsiteY7"/>
+                <a:pos x="csX7" y="csY7"/>
               </a:cxn>
               <a:cxn ang="0">
-                <a:pos x="connsiteX8" y="connsiteY8"/>
+                <a:pos x="csX8" y="csY8"/>
               </a:cxn>
               <a:cxn ang="0">
-                <a:pos x="connsiteX9" y="connsiteY9"/>
+                <a:pos x="csX9" y="csY9"/>
               </a:cxn>
               <a:cxn ang="0">
-                <a:pos x="connsiteX10" y="connsiteY10"/>
+                <a:pos x="csX10" y="csY10"/>
               </a:cxn>
               <a:cxn ang="0">
-                <a:pos x="connsiteX11" y="connsiteY11"/>
+                <a:pos x="csX11" y="csY11"/>
               </a:cxn>
             </a:cxnLst>
             <a:rect l="l" t="t" r="r" b="b"/>
@@ -10285,188 +10285,188 @@
           <a:custGeom>
             <a:avLst/>
             <a:gdLst>
-              <a:gd name="connsiteX0" fmla="*/ 0 w 10853928"/>
-              <a:gd name="connsiteY0" fmla="*/ 0 h 18288"/>
-              <a:gd name="connsiteX1" fmla="*/ 461292 w 10853928"/>
-              <a:gd name="connsiteY1" fmla="*/ 0 h 18288"/>
-              <a:gd name="connsiteX2" fmla="*/ 1139662 w 10853928"/>
-              <a:gd name="connsiteY2" fmla="*/ 0 h 18288"/>
-              <a:gd name="connsiteX3" fmla="*/ 1926572 w 10853928"/>
-              <a:gd name="connsiteY3" fmla="*/ 0 h 18288"/>
-              <a:gd name="connsiteX4" fmla="*/ 2279325 w 10853928"/>
-              <a:gd name="connsiteY4" fmla="*/ 0 h 18288"/>
-              <a:gd name="connsiteX5" fmla="*/ 2632078 w 10853928"/>
-              <a:gd name="connsiteY5" fmla="*/ 0 h 18288"/>
-              <a:gd name="connsiteX6" fmla="*/ 3527527 w 10853928"/>
-              <a:gd name="connsiteY6" fmla="*/ 0 h 18288"/>
-              <a:gd name="connsiteX7" fmla="*/ 4205897 w 10853928"/>
-              <a:gd name="connsiteY7" fmla="*/ 0 h 18288"/>
-              <a:gd name="connsiteX8" fmla="*/ 4558650 w 10853928"/>
-              <a:gd name="connsiteY8" fmla="*/ 0 h 18288"/>
-              <a:gd name="connsiteX9" fmla="*/ 5237020 w 10853928"/>
-              <a:gd name="connsiteY9" fmla="*/ 0 h 18288"/>
-              <a:gd name="connsiteX10" fmla="*/ 6132469 w 10853928"/>
-              <a:gd name="connsiteY10" fmla="*/ 0 h 18288"/>
-              <a:gd name="connsiteX11" fmla="*/ 6702301 w 10853928"/>
-              <a:gd name="connsiteY11" fmla="*/ 0 h 18288"/>
-              <a:gd name="connsiteX12" fmla="*/ 7272132 w 10853928"/>
-              <a:gd name="connsiteY12" fmla="*/ 0 h 18288"/>
-              <a:gd name="connsiteX13" fmla="*/ 7950502 w 10853928"/>
-              <a:gd name="connsiteY13" fmla="*/ 0 h 18288"/>
-              <a:gd name="connsiteX14" fmla="*/ 8737412 w 10853928"/>
-              <a:gd name="connsiteY14" fmla="*/ 0 h 18288"/>
-              <a:gd name="connsiteX15" fmla="*/ 9524322 w 10853928"/>
-              <a:gd name="connsiteY15" fmla="*/ 0 h 18288"/>
-              <a:gd name="connsiteX16" fmla="*/ 10853928 w 10853928"/>
-              <a:gd name="connsiteY16" fmla="*/ 0 h 18288"/>
-              <a:gd name="connsiteX17" fmla="*/ 10853928 w 10853928"/>
-              <a:gd name="connsiteY17" fmla="*/ 18288 h 18288"/>
-              <a:gd name="connsiteX18" fmla="*/ 10392636 w 10853928"/>
-              <a:gd name="connsiteY18" fmla="*/ 18288 h 18288"/>
-              <a:gd name="connsiteX19" fmla="*/ 9497187 w 10853928"/>
-              <a:gd name="connsiteY19" fmla="*/ 18288 h 18288"/>
-              <a:gd name="connsiteX20" fmla="*/ 8818817 w 10853928"/>
-              <a:gd name="connsiteY20" fmla="*/ 18288 h 18288"/>
-              <a:gd name="connsiteX21" fmla="*/ 8466064 w 10853928"/>
-              <a:gd name="connsiteY21" fmla="*/ 18288 h 18288"/>
-              <a:gd name="connsiteX22" fmla="*/ 7787693 w 10853928"/>
-              <a:gd name="connsiteY22" fmla="*/ 18288 h 18288"/>
-              <a:gd name="connsiteX23" fmla="*/ 7217862 w 10853928"/>
-              <a:gd name="connsiteY23" fmla="*/ 18288 h 18288"/>
-              <a:gd name="connsiteX24" fmla="*/ 6648031 w 10853928"/>
-              <a:gd name="connsiteY24" fmla="*/ 18288 h 18288"/>
-              <a:gd name="connsiteX25" fmla="*/ 6078200 w 10853928"/>
-              <a:gd name="connsiteY25" fmla="*/ 18288 h 18288"/>
-              <a:gd name="connsiteX26" fmla="*/ 5508368 w 10853928"/>
-              <a:gd name="connsiteY26" fmla="*/ 18288 h 18288"/>
-              <a:gd name="connsiteX27" fmla="*/ 4721459 w 10853928"/>
-              <a:gd name="connsiteY27" fmla="*/ 18288 h 18288"/>
-              <a:gd name="connsiteX28" fmla="*/ 4043088 w 10853928"/>
-              <a:gd name="connsiteY28" fmla="*/ 18288 h 18288"/>
-              <a:gd name="connsiteX29" fmla="*/ 3690336 w 10853928"/>
-              <a:gd name="connsiteY29" fmla="*/ 18288 h 18288"/>
-              <a:gd name="connsiteX30" fmla="*/ 3120504 w 10853928"/>
-              <a:gd name="connsiteY30" fmla="*/ 18288 h 18288"/>
-              <a:gd name="connsiteX31" fmla="*/ 2333595 w 10853928"/>
-              <a:gd name="connsiteY31" fmla="*/ 18288 h 18288"/>
-              <a:gd name="connsiteX32" fmla="*/ 1872303 w 10853928"/>
-              <a:gd name="connsiteY32" fmla="*/ 18288 h 18288"/>
-              <a:gd name="connsiteX33" fmla="*/ 976854 w 10853928"/>
-              <a:gd name="connsiteY33" fmla="*/ 18288 h 18288"/>
-              <a:gd name="connsiteX34" fmla="*/ 0 w 10853928"/>
-              <a:gd name="connsiteY34" fmla="*/ 18288 h 18288"/>
-              <a:gd name="connsiteX35" fmla="*/ 0 w 10853928"/>
-              <a:gd name="connsiteY35" fmla="*/ 0 h 18288"/>
+              <a:gd name="csX0" fmla="*/ 0 w 10853928"/>
+              <a:gd name="csY0" fmla="*/ 0 h 18288"/>
+              <a:gd name="csX1" fmla="*/ 461292 w 10853928"/>
+              <a:gd name="csY1" fmla="*/ 0 h 18288"/>
+              <a:gd name="csX2" fmla="*/ 1139662 w 10853928"/>
+              <a:gd name="csY2" fmla="*/ 0 h 18288"/>
+              <a:gd name="csX3" fmla="*/ 1926572 w 10853928"/>
+              <a:gd name="csY3" fmla="*/ 0 h 18288"/>
+              <a:gd name="csX4" fmla="*/ 2279325 w 10853928"/>
+              <a:gd name="csY4" fmla="*/ 0 h 18288"/>
+              <a:gd name="csX5" fmla="*/ 2632078 w 10853928"/>
+              <a:gd name="csY5" fmla="*/ 0 h 18288"/>
+              <a:gd name="csX6" fmla="*/ 3527527 w 10853928"/>
+              <a:gd name="csY6" fmla="*/ 0 h 18288"/>
+              <a:gd name="csX7" fmla="*/ 4205897 w 10853928"/>
+              <a:gd name="csY7" fmla="*/ 0 h 18288"/>
+              <a:gd name="csX8" fmla="*/ 4558650 w 10853928"/>
+              <a:gd name="csY8" fmla="*/ 0 h 18288"/>
+              <a:gd name="csX9" fmla="*/ 5237020 w 10853928"/>
+              <a:gd name="csY9" fmla="*/ 0 h 18288"/>
+              <a:gd name="csX10" fmla="*/ 6132469 w 10853928"/>
+              <a:gd name="csY10" fmla="*/ 0 h 18288"/>
+              <a:gd name="csX11" fmla="*/ 6702301 w 10853928"/>
+              <a:gd name="csY11" fmla="*/ 0 h 18288"/>
+              <a:gd name="csX12" fmla="*/ 7272132 w 10853928"/>
+              <a:gd name="csY12" fmla="*/ 0 h 18288"/>
+              <a:gd name="csX13" fmla="*/ 7950502 w 10853928"/>
+              <a:gd name="csY13" fmla="*/ 0 h 18288"/>
+              <a:gd name="csX14" fmla="*/ 8737412 w 10853928"/>
+              <a:gd name="csY14" fmla="*/ 0 h 18288"/>
+              <a:gd name="csX15" fmla="*/ 9524322 w 10853928"/>
+              <a:gd name="csY15" fmla="*/ 0 h 18288"/>
+              <a:gd name="csX16" fmla="*/ 10853928 w 10853928"/>
+              <a:gd name="csY16" fmla="*/ 0 h 18288"/>
+              <a:gd name="csX17" fmla="*/ 10853928 w 10853928"/>
+              <a:gd name="csY17" fmla="*/ 18288 h 18288"/>
+              <a:gd name="csX18" fmla="*/ 10392636 w 10853928"/>
+              <a:gd name="csY18" fmla="*/ 18288 h 18288"/>
+              <a:gd name="csX19" fmla="*/ 9497187 w 10853928"/>
+              <a:gd name="csY19" fmla="*/ 18288 h 18288"/>
+              <a:gd name="csX20" fmla="*/ 8818817 w 10853928"/>
+              <a:gd name="csY20" fmla="*/ 18288 h 18288"/>
+              <a:gd name="csX21" fmla="*/ 8466064 w 10853928"/>
+              <a:gd name="csY21" fmla="*/ 18288 h 18288"/>
+              <a:gd name="csX22" fmla="*/ 7787693 w 10853928"/>
+              <a:gd name="csY22" fmla="*/ 18288 h 18288"/>
+              <a:gd name="csX23" fmla="*/ 7217862 w 10853928"/>
+              <a:gd name="csY23" fmla="*/ 18288 h 18288"/>
+              <a:gd name="csX24" fmla="*/ 6648031 w 10853928"/>
+              <a:gd name="csY24" fmla="*/ 18288 h 18288"/>
+              <a:gd name="csX25" fmla="*/ 6078200 w 10853928"/>
+              <a:gd name="csY25" fmla="*/ 18288 h 18288"/>
+              <a:gd name="csX26" fmla="*/ 5508368 w 10853928"/>
+              <a:gd name="csY26" fmla="*/ 18288 h 18288"/>
+              <a:gd name="csX27" fmla="*/ 4721459 w 10853928"/>
+              <a:gd name="csY27" fmla="*/ 18288 h 18288"/>
+              <a:gd name="csX28" fmla="*/ 4043088 w 10853928"/>
+              <a:gd name="csY28" fmla="*/ 18288 h 18288"/>
+              <a:gd name="csX29" fmla="*/ 3690336 w 10853928"/>
+              <a:gd name="csY29" fmla="*/ 18288 h 18288"/>
+              <a:gd name="csX30" fmla="*/ 3120504 w 10853928"/>
+              <a:gd name="csY30" fmla="*/ 18288 h 18288"/>
+              <a:gd name="csX31" fmla="*/ 2333595 w 10853928"/>
+              <a:gd name="csY31" fmla="*/ 18288 h 18288"/>
+              <a:gd name="csX32" fmla="*/ 1872303 w 10853928"/>
+              <a:gd name="csY32" fmla="*/ 18288 h 18288"/>
+              <a:gd name="csX33" fmla="*/ 976854 w 10853928"/>
+              <a:gd name="csY33" fmla="*/ 18288 h 18288"/>
+              <a:gd name="csX34" fmla="*/ 0 w 10853928"/>
+              <a:gd name="csY34" fmla="*/ 18288 h 18288"/>
+              <a:gd name="csX35" fmla="*/ 0 w 10853928"/>
+              <a:gd name="csY35" fmla="*/ 0 h 18288"/>
             </a:gdLst>
             <a:ahLst/>
             <a:cxnLst>
               <a:cxn ang="0">
-                <a:pos x="connsiteX0" y="connsiteY0"/>
+                <a:pos x="csX0" y="csY0"/>
               </a:cxn>
               <a:cxn ang="0">
-                <a:pos x="connsiteX1" y="connsiteY1"/>
+                <a:pos x="csX1" y="csY1"/>
               </a:cxn>
               <a:cxn ang="0">
-                <a:pos x="connsiteX2" y="connsiteY2"/>
+                <a:pos x="csX2" y="csY2"/>
               </a:cxn>
               <a:cxn ang="0">
-                <a:pos x="connsiteX3" y="connsiteY3"/>
+                <a:pos x="csX3" y="csY3"/>
               </a:cxn>
               <a:cxn ang="0">
-                <a:pos x="connsiteX4" y="connsiteY4"/>
+                <a:pos x="csX4" y="csY4"/>
               </a:cxn>
               <a:cxn ang="0">
-                <a:pos x="connsiteX5" y="connsiteY5"/>
+                <a:pos x="csX5" y="csY5"/>
               </a:cxn>
               <a:cxn ang="0">
-                <a:pos x="connsiteX6" y="connsiteY6"/>
+                <a:pos x="csX6" y="csY6"/>
               </a:cxn>
               <a:cxn ang="0">
-                <a:pos x="connsiteX7" y="connsiteY7"/>
+                <a:pos x="csX7" y="csY7"/>
               </a:cxn>
               <a:cxn ang="0">
-                <a:pos x="connsiteX8" y="connsiteY8"/>
+                <a:pos x="csX8" y="csY8"/>
               </a:cxn>
               <a:cxn ang="0">
-                <a:pos x="connsiteX9" y="connsiteY9"/>
+                <a:pos x="csX9" y="csY9"/>
               </a:cxn>
               <a:cxn ang="0">
-                <a:pos x="connsiteX10" y="connsiteY10"/>
+                <a:pos x="csX10" y="csY10"/>
               </a:cxn>
               <a:cxn ang="0">
-                <a:pos x="connsiteX11" y="connsiteY11"/>
+                <a:pos x="csX11" y="csY11"/>
               </a:cxn>
               <a:cxn ang="0">
-                <a:pos x="connsiteX12" y="connsiteY12"/>
+                <a:pos x="csX12" y="csY12"/>
               </a:cxn>
               <a:cxn ang="0">
-                <a:pos x="connsiteX13" y="connsiteY13"/>
+                <a:pos x="csX13" y="csY13"/>
               </a:cxn>
               <a:cxn ang="0">
-                <a:pos x="connsiteX14" y="connsiteY14"/>
+                <a:pos x="csX14" y="csY14"/>
               </a:cxn>
               <a:cxn ang="0">
-                <a:pos x="connsiteX15" y="connsiteY15"/>
+                <a:pos x="csX15" y="csY15"/>
               </a:cxn>
               <a:cxn ang="0">
-                <a:pos x="connsiteX16" y="connsiteY16"/>
+                <a:pos x="csX16" y="csY16"/>
               </a:cxn>
               <a:cxn ang="0">
-                <a:pos x="connsiteX17" y="connsiteY17"/>
+                <a:pos x="csX17" y="csY17"/>
               </a:cxn>
               <a:cxn ang="0">
-                <a:pos x="connsiteX18" y="connsiteY18"/>
+                <a:pos x="csX18" y="csY18"/>
               </a:cxn>
               <a:cxn ang="0">
-                <a:pos x="connsiteX19" y="connsiteY19"/>
+                <a:pos x="csX19" y="csY19"/>
               </a:cxn>
               <a:cxn ang="0">
-                <a:pos x="connsiteX20" y="connsiteY20"/>
+                <a:pos x="csX20" y="csY20"/>
               </a:cxn>
               <a:cxn ang="0">
-                <a:pos x="connsiteX21" y="connsiteY21"/>
+                <a:pos x="csX21" y="csY21"/>
               </a:cxn>
               <a:cxn ang="0">
-                <a:pos x="connsiteX22" y="connsiteY22"/>
+                <a:pos x="csX22" y="csY22"/>
               </a:cxn>
               <a:cxn ang="0">
-                <a:pos x="connsiteX23" y="connsiteY23"/>
+                <a:pos x="csX23" y="csY23"/>
               </a:cxn>
               <a:cxn ang="0">
-                <a:pos x="connsiteX24" y="connsiteY24"/>
+                <a:pos x="csX24" y="csY24"/>
               </a:cxn>
               <a:cxn ang="0">
-                <a:pos x="connsiteX25" y="connsiteY25"/>
+                <a:pos x="csX25" y="csY25"/>
               </a:cxn>
               <a:cxn ang="0">
-                <a:pos x="connsiteX26" y="connsiteY26"/>
+                <a:pos x="csX26" y="csY26"/>
               </a:cxn>
               <a:cxn ang="0">
-                <a:pos x="connsiteX27" y="connsiteY27"/>
+                <a:pos x="csX27" y="csY27"/>
               </a:cxn>
               <a:cxn ang="0">
-                <a:pos x="connsiteX28" y="connsiteY28"/>
+                <a:pos x="csX28" y="csY28"/>
               </a:cxn>
               <a:cxn ang="0">
-                <a:pos x="connsiteX29" y="connsiteY29"/>
+                <a:pos x="csX29" y="csY29"/>
               </a:cxn>
               <a:cxn ang="0">
-                <a:pos x="connsiteX30" y="connsiteY30"/>
+                <a:pos x="csX30" y="csY30"/>
               </a:cxn>
               <a:cxn ang="0">
-                <a:pos x="connsiteX31" y="connsiteY31"/>
+                <a:pos x="csX31" y="csY31"/>
               </a:cxn>
               <a:cxn ang="0">
-                <a:pos x="connsiteX32" y="connsiteY32"/>
+                <a:pos x="csX32" y="csY32"/>
               </a:cxn>
               <a:cxn ang="0">
-                <a:pos x="connsiteX33" y="connsiteY33"/>
+                <a:pos x="csX33" y="csY33"/>
               </a:cxn>
               <a:cxn ang="0">
-                <a:pos x="connsiteX34" y="connsiteY34"/>
+                <a:pos x="csX34" y="csY34"/>
               </a:cxn>
               <a:cxn ang="0">
-                <a:pos x="connsiteX35" y="connsiteY35"/>
+                <a:pos x="csX35" y="csY35"/>
               </a:cxn>
             </a:cxnLst>
             <a:rect l="l" t="t" r="r" b="b"/>
@@ -11413,68 +11413,68 @@
           <a:custGeom>
             <a:avLst/>
             <a:gdLst>
-              <a:gd name="connsiteX0" fmla="*/ 0 w 3255095"/>
-              <a:gd name="connsiteY0" fmla="*/ 0 h 18288"/>
-              <a:gd name="connsiteX1" fmla="*/ 618468 w 3255095"/>
-              <a:gd name="connsiteY1" fmla="*/ 0 h 18288"/>
-              <a:gd name="connsiteX2" fmla="*/ 1269487 w 3255095"/>
-              <a:gd name="connsiteY2" fmla="*/ 0 h 18288"/>
-              <a:gd name="connsiteX3" fmla="*/ 1953057 w 3255095"/>
-              <a:gd name="connsiteY3" fmla="*/ 0 h 18288"/>
-              <a:gd name="connsiteX4" fmla="*/ 2636627 w 3255095"/>
-              <a:gd name="connsiteY4" fmla="*/ 0 h 18288"/>
-              <a:gd name="connsiteX5" fmla="*/ 3255095 w 3255095"/>
-              <a:gd name="connsiteY5" fmla="*/ 0 h 18288"/>
-              <a:gd name="connsiteX6" fmla="*/ 3255095 w 3255095"/>
-              <a:gd name="connsiteY6" fmla="*/ 18288 h 18288"/>
-              <a:gd name="connsiteX7" fmla="*/ 2538974 w 3255095"/>
-              <a:gd name="connsiteY7" fmla="*/ 18288 h 18288"/>
-              <a:gd name="connsiteX8" fmla="*/ 1822853 w 3255095"/>
-              <a:gd name="connsiteY8" fmla="*/ 18288 h 18288"/>
-              <a:gd name="connsiteX9" fmla="*/ 1171834 w 3255095"/>
-              <a:gd name="connsiteY9" fmla="*/ 18288 h 18288"/>
-              <a:gd name="connsiteX10" fmla="*/ 0 w 3255095"/>
-              <a:gd name="connsiteY10" fmla="*/ 18288 h 18288"/>
-              <a:gd name="connsiteX11" fmla="*/ 0 w 3255095"/>
-              <a:gd name="connsiteY11" fmla="*/ 0 h 18288"/>
+              <a:gd name="csX0" fmla="*/ 0 w 3255095"/>
+              <a:gd name="csY0" fmla="*/ 0 h 18288"/>
+              <a:gd name="csX1" fmla="*/ 618468 w 3255095"/>
+              <a:gd name="csY1" fmla="*/ 0 h 18288"/>
+              <a:gd name="csX2" fmla="*/ 1269487 w 3255095"/>
+              <a:gd name="csY2" fmla="*/ 0 h 18288"/>
+              <a:gd name="csX3" fmla="*/ 1953057 w 3255095"/>
+              <a:gd name="csY3" fmla="*/ 0 h 18288"/>
+              <a:gd name="csX4" fmla="*/ 2636627 w 3255095"/>
+              <a:gd name="csY4" fmla="*/ 0 h 18288"/>
+              <a:gd name="csX5" fmla="*/ 3255095 w 3255095"/>
+              <a:gd name="csY5" fmla="*/ 0 h 18288"/>
+              <a:gd name="csX6" fmla="*/ 3255095 w 3255095"/>
+              <a:gd name="csY6" fmla="*/ 18288 h 18288"/>
+              <a:gd name="csX7" fmla="*/ 2538974 w 3255095"/>
+              <a:gd name="csY7" fmla="*/ 18288 h 18288"/>
+              <a:gd name="csX8" fmla="*/ 1822853 w 3255095"/>
+              <a:gd name="csY8" fmla="*/ 18288 h 18288"/>
+              <a:gd name="csX9" fmla="*/ 1171834 w 3255095"/>
+              <a:gd name="csY9" fmla="*/ 18288 h 18288"/>
+              <a:gd name="csX10" fmla="*/ 0 w 3255095"/>
+              <a:gd name="csY10" fmla="*/ 18288 h 18288"/>
+              <a:gd name="csX11" fmla="*/ 0 w 3255095"/>
+              <a:gd name="csY11" fmla="*/ 0 h 18288"/>
             </a:gdLst>
             <a:ahLst/>
             <a:cxnLst>
               <a:cxn ang="0">
-                <a:pos x="connsiteX0" y="connsiteY0"/>
+                <a:pos x="csX0" y="csY0"/>
               </a:cxn>
               <a:cxn ang="0">
-                <a:pos x="connsiteX1" y="connsiteY1"/>
+                <a:pos x="csX1" y="csY1"/>
               </a:cxn>
               <a:cxn ang="0">
-                <a:pos x="connsiteX2" y="connsiteY2"/>
+                <a:pos x="csX2" y="csY2"/>
               </a:cxn>
               <a:cxn ang="0">
-                <a:pos x="connsiteX3" y="connsiteY3"/>
+                <a:pos x="csX3" y="csY3"/>
               </a:cxn>
               <a:cxn ang="0">
-                <a:pos x="connsiteX4" y="connsiteY4"/>
+                <a:pos x="csX4" y="csY4"/>
               </a:cxn>
               <a:cxn ang="0">
-                <a:pos x="connsiteX5" y="connsiteY5"/>
+                <a:pos x="csX5" y="csY5"/>
               </a:cxn>
               <a:cxn ang="0">
-                <a:pos x="connsiteX6" y="connsiteY6"/>
+                <a:pos x="csX6" y="csY6"/>
               </a:cxn>
               <a:cxn ang="0">
-                <a:pos x="connsiteX7" y="connsiteY7"/>
+                <a:pos x="csX7" y="csY7"/>
               </a:cxn>
               <a:cxn ang="0">
-                <a:pos x="connsiteX8" y="connsiteY8"/>
+                <a:pos x="csX8" y="csY8"/>
               </a:cxn>
               <a:cxn ang="0">
-                <a:pos x="connsiteX9" y="connsiteY9"/>
+                <a:pos x="csX9" y="csY9"/>
               </a:cxn>
               <a:cxn ang="0">
-                <a:pos x="connsiteX10" y="connsiteY10"/>
+                <a:pos x="csX10" y="csY10"/>
               </a:cxn>
               <a:cxn ang="0">
-                <a:pos x="connsiteX11" y="connsiteY11"/>
+                <a:pos x="csX11" y="csY11"/>
               </a:cxn>
             </a:cxnLst>
             <a:rect l="l" t="t" r="r" b="b"/>
@@ -13516,73 +13516,73 @@
           <a:custGeom>
             <a:avLst/>
             <a:gdLst>
-              <a:gd name="connsiteX0" fmla="*/ 0 w 3474720"/>
-              <a:gd name="connsiteY0" fmla="*/ 0 h 18288"/>
-              <a:gd name="connsiteX1" fmla="*/ 694944 w 3474720"/>
-              <a:gd name="connsiteY1" fmla="*/ 0 h 18288"/>
-              <a:gd name="connsiteX2" fmla="*/ 1355141 w 3474720"/>
-              <a:gd name="connsiteY2" fmla="*/ 0 h 18288"/>
-              <a:gd name="connsiteX3" fmla="*/ 2015338 w 3474720"/>
-              <a:gd name="connsiteY3" fmla="*/ 0 h 18288"/>
-              <a:gd name="connsiteX4" fmla="*/ 2779776 w 3474720"/>
-              <a:gd name="connsiteY4" fmla="*/ 0 h 18288"/>
-              <a:gd name="connsiteX5" fmla="*/ 3474720 w 3474720"/>
-              <a:gd name="connsiteY5" fmla="*/ 0 h 18288"/>
-              <a:gd name="connsiteX6" fmla="*/ 3474720 w 3474720"/>
-              <a:gd name="connsiteY6" fmla="*/ 18288 h 18288"/>
-              <a:gd name="connsiteX7" fmla="*/ 2779776 w 3474720"/>
-              <a:gd name="connsiteY7" fmla="*/ 18288 h 18288"/>
-              <a:gd name="connsiteX8" fmla="*/ 2189074 w 3474720"/>
-              <a:gd name="connsiteY8" fmla="*/ 18288 h 18288"/>
-              <a:gd name="connsiteX9" fmla="*/ 1528877 w 3474720"/>
-              <a:gd name="connsiteY9" fmla="*/ 18288 h 18288"/>
-              <a:gd name="connsiteX10" fmla="*/ 868680 w 3474720"/>
-              <a:gd name="connsiteY10" fmla="*/ 18288 h 18288"/>
-              <a:gd name="connsiteX11" fmla="*/ 0 w 3474720"/>
-              <a:gd name="connsiteY11" fmla="*/ 18288 h 18288"/>
-              <a:gd name="connsiteX12" fmla="*/ 0 w 3474720"/>
-              <a:gd name="connsiteY12" fmla="*/ 0 h 18288"/>
+              <a:gd name="csX0" fmla="*/ 0 w 3474720"/>
+              <a:gd name="csY0" fmla="*/ 0 h 18288"/>
+              <a:gd name="csX1" fmla="*/ 694944 w 3474720"/>
+              <a:gd name="csY1" fmla="*/ 0 h 18288"/>
+              <a:gd name="csX2" fmla="*/ 1355141 w 3474720"/>
+              <a:gd name="csY2" fmla="*/ 0 h 18288"/>
+              <a:gd name="csX3" fmla="*/ 2015338 w 3474720"/>
+              <a:gd name="csY3" fmla="*/ 0 h 18288"/>
+              <a:gd name="csX4" fmla="*/ 2779776 w 3474720"/>
+              <a:gd name="csY4" fmla="*/ 0 h 18288"/>
+              <a:gd name="csX5" fmla="*/ 3474720 w 3474720"/>
+              <a:gd name="csY5" fmla="*/ 0 h 18288"/>
+              <a:gd name="csX6" fmla="*/ 3474720 w 3474720"/>
+              <a:gd name="csY6" fmla="*/ 18288 h 18288"/>
+              <a:gd name="csX7" fmla="*/ 2779776 w 3474720"/>
+              <a:gd name="csY7" fmla="*/ 18288 h 18288"/>
+              <a:gd name="csX8" fmla="*/ 2189074 w 3474720"/>
+              <a:gd name="csY8" fmla="*/ 18288 h 18288"/>
+              <a:gd name="csX9" fmla="*/ 1528877 w 3474720"/>
+              <a:gd name="csY9" fmla="*/ 18288 h 18288"/>
+              <a:gd name="csX10" fmla="*/ 868680 w 3474720"/>
+              <a:gd name="csY10" fmla="*/ 18288 h 18288"/>
+              <a:gd name="csX11" fmla="*/ 0 w 3474720"/>
+              <a:gd name="csY11" fmla="*/ 18288 h 18288"/>
+              <a:gd name="csX12" fmla="*/ 0 w 3474720"/>
+              <a:gd name="csY12" fmla="*/ 0 h 18288"/>
             </a:gdLst>
             <a:ahLst/>
             <a:cxnLst>
               <a:cxn ang="0">
-                <a:pos x="connsiteX0" y="connsiteY0"/>
+                <a:pos x="csX0" y="csY0"/>
               </a:cxn>
               <a:cxn ang="0">
-                <a:pos x="connsiteX1" y="connsiteY1"/>
+                <a:pos x="csX1" y="csY1"/>
               </a:cxn>
               <a:cxn ang="0">
-                <a:pos x="connsiteX2" y="connsiteY2"/>
+                <a:pos x="csX2" y="csY2"/>
               </a:cxn>
               <a:cxn ang="0">
-                <a:pos x="connsiteX3" y="connsiteY3"/>
+                <a:pos x="csX3" y="csY3"/>
               </a:cxn>
               <a:cxn ang="0">
-                <a:pos x="connsiteX4" y="connsiteY4"/>
+                <a:pos x="csX4" y="csY4"/>
               </a:cxn>
               <a:cxn ang="0">
-                <a:pos x="connsiteX5" y="connsiteY5"/>
+                <a:pos x="csX5" y="csY5"/>
               </a:cxn>
               <a:cxn ang="0">
-                <a:pos x="connsiteX6" y="connsiteY6"/>
+                <a:pos x="csX6" y="csY6"/>
               </a:cxn>
               <a:cxn ang="0">
-                <a:pos x="connsiteX7" y="connsiteY7"/>
+                <a:pos x="csX7" y="csY7"/>
               </a:cxn>
               <a:cxn ang="0">
-                <a:pos x="connsiteX8" y="connsiteY8"/>
+                <a:pos x="csX8" y="csY8"/>
               </a:cxn>
               <a:cxn ang="0">
-                <a:pos x="connsiteX9" y="connsiteY9"/>
+                <a:pos x="csX9" y="csY9"/>
               </a:cxn>
               <a:cxn ang="0">
-                <a:pos x="connsiteX10" y="connsiteY10"/>
+                <a:pos x="csX10" y="csY10"/>
               </a:cxn>
               <a:cxn ang="0">
-                <a:pos x="connsiteX11" y="connsiteY11"/>
+                <a:pos x="csX11" y="csY11"/>
               </a:cxn>
               <a:cxn ang="0">
-                <a:pos x="connsiteX12" y="connsiteY12"/>
+                <a:pos x="csX12" y="csY12"/>
               </a:cxn>
             </a:cxnLst>
             <a:rect l="l" t="t" r="r" b="b"/>
@@ -16782,53 +16782,53 @@
           <a:custGeom>
             <a:avLst/>
             <a:gdLst>
-              <a:gd name="connsiteX0" fmla="*/ 0 w 1554480"/>
-              <a:gd name="connsiteY0" fmla="*/ 0 h 18288"/>
-              <a:gd name="connsiteX1" fmla="*/ 549250 w 1554480"/>
-              <a:gd name="connsiteY1" fmla="*/ 0 h 18288"/>
-              <a:gd name="connsiteX2" fmla="*/ 1082954 w 1554480"/>
-              <a:gd name="connsiteY2" fmla="*/ 0 h 18288"/>
-              <a:gd name="connsiteX3" fmla="*/ 1554480 w 1554480"/>
-              <a:gd name="connsiteY3" fmla="*/ 0 h 18288"/>
-              <a:gd name="connsiteX4" fmla="*/ 1554480 w 1554480"/>
-              <a:gd name="connsiteY4" fmla="*/ 18288 h 18288"/>
-              <a:gd name="connsiteX5" fmla="*/ 1067410 w 1554480"/>
-              <a:gd name="connsiteY5" fmla="*/ 18288 h 18288"/>
-              <a:gd name="connsiteX6" fmla="*/ 549250 w 1554480"/>
-              <a:gd name="connsiteY6" fmla="*/ 18288 h 18288"/>
-              <a:gd name="connsiteX7" fmla="*/ 0 w 1554480"/>
-              <a:gd name="connsiteY7" fmla="*/ 18288 h 18288"/>
-              <a:gd name="connsiteX8" fmla="*/ 0 w 1554480"/>
-              <a:gd name="connsiteY8" fmla="*/ 0 h 18288"/>
+              <a:gd name="csX0" fmla="*/ 0 w 1554480"/>
+              <a:gd name="csY0" fmla="*/ 0 h 18288"/>
+              <a:gd name="csX1" fmla="*/ 549250 w 1554480"/>
+              <a:gd name="csY1" fmla="*/ 0 h 18288"/>
+              <a:gd name="csX2" fmla="*/ 1082954 w 1554480"/>
+              <a:gd name="csY2" fmla="*/ 0 h 18288"/>
+              <a:gd name="csX3" fmla="*/ 1554480 w 1554480"/>
+              <a:gd name="csY3" fmla="*/ 0 h 18288"/>
+              <a:gd name="csX4" fmla="*/ 1554480 w 1554480"/>
+              <a:gd name="csY4" fmla="*/ 18288 h 18288"/>
+              <a:gd name="csX5" fmla="*/ 1067410 w 1554480"/>
+              <a:gd name="csY5" fmla="*/ 18288 h 18288"/>
+              <a:gd name="csX6" fmla="*/ 549250 w 1554480"/>
+              <a:gd name="csY6" fmla="*/ 18288 h 18288"/>
+              <a:gd name="csX7" fmla="*/ 0 w 1554480"/>
+              <a:gd name="csY7" fmla="*/ 18288 h 18288"/>
+              <a:gd name="csX8" fmla="*/ 0 w 1554480"/>
+              <a:gd name="csY8" fmla="*/ 0 h 18288"/>
             </a:gdLst>
             <a:ahLst/>
             <a:cxnLst>
               <a:cxn ang="0">
-                <a:pos x="connsiteX0" y="connsiteY0"/>
+                <a:pos x="csX0" y="csY0"/>
               </a:cxn>
               <a:cxn ang="0">
-                <a:pos x="connsiteX1" y="connsiteY1"/>
+                <a:pos x="csX1" y="csY1"/>
               </a:cxn>
               <a:cxn ang="0">
-                <a:pos x="connsiteX2" y="connsiteY2"/>
+                <a:pos x="csX2" y="csY2"/>
               </a:cxn>
               <a:cxn ang="0">
-                <a:pos x="connsiteX3" y="connsiteY3"/>
+                <a:pos x="csX3" y="csY3"/>
               </a:cxn>
               <a:cxn ang="0">
-                <a:pos x="connsiteX4" y="connsiteY4"/>
+                <a:pos x="csX4" y="csY4"/>
               </a:cxn>
               <a:cxn ang="0">
-                <a:pos x="connsiteX5" y="connsiteY5"/>
+                <a:pos x="csX5" y="csY5"/>
               </a:cxn>
               <a:cxn ang="0">
-                <a:pos x="connsiteX6" y="connsiteY6"/>
+                <a:pos x="csX6" y="csY6"/>
               </a:cxn>
               <a:cxn ang="0">
-                <a:pos x="connsiteX7" y="connsiteY7"/>
+                <a:pos x="csX7" y="csY7"/>
               </a:cxn>
               <a:cxn ang="0">
-                <a:pos x="connsiteX8" y="connsiteY8"/>
+                <a:pos x="csX8" y="csY8"/>
               </a:cxn>
             </a:cxnLst>
             <a:rect l="l" t="t" r="r" b="b"/>
@@ -17846,108 +17846,108 @@
           <a:custGeom>
             <a:avLst/>
             <a:gdLst>
-              <a:gd name="connsiteX0" fmla="*/ 0 w 18288"/>
-              <a:gd name="connsiteY0" fmla="*/ 0 h 5590381"/>
-              <a:gd name="connsiteX1" fmla="*/ 18288 w 18288"/>
-              <a:gd name="connsiteY1" fmla="*/ 0 h 5590381"/>
-              <a:gd name="connsiteX2" fmla="*/ 18288 w 18288"/>
-              <a:gd name="connsiteY2" fmla="*/ 754701 h 5590381"/>
-              <a:gd name="connsiteX3" fmla="*/ 18288 w 18288"/>
-              <a:gd name="connsiteY3" fmla="*/ 1565307 h 5590381"/>
-              <a:gd name="connsiteX4" fmla="*/ 18288 w 18288"/>
-              <a:gd name="connsiteY4" fmla="*/ 2152297 h 5590381"/>
-              <a:gd name="connsiteX5" fmla="*/ 18288 w 18288"/>
-              <a:gd name="connsiteY5" fmla="*/ 2906998 h 5590381"/>
-              <a:gd name="connsiteX6" fmla="*/ 18288 w 18288"/>
-              <a:gd name="connsiteY6" fmla="*/ 3549892 h 5590381"/>
-              <a:gd name="connsiteX7" fmla="*/ 18288 w 18288"/>
-              <a:gd name="connsiteY7" fmla="*/ 4080978 h 5590381"/>
-              <a:gd name="connsiteX8" fmla="*/ 18288 w 18288"/>
-              <a:gd name="connsiteY8" fmla="*/ 4835680 h 5590381"/>
-              <a:gd name="connsiteX9" fmla="*/ 18288 w 18288"/>
-              <a:gd name="connsiteY9" fmla="*/ 5590381 h 5590381"/>
-              <a:gd name="connsiteX10" fmla="*/ 0 w 18288"/>
-              <a:gd name="connsiteY10" fmla="*/ 5590381 h 5590381"/>
-              <a:gd name="connsiteX11" fmla="*/ 0 w 18288"/>
-              <a:gd name="connsiteY11" fmla="*/ 4835680 h 5590381"/>
-              <a:gd name="connsiteX12" fmla="*/ 0 w 18288"/>
-              <a:gd name="connsiteY12" fmla="*/ 4304593 h 5590381"/>
-              <a:gd name="connsiteX13" fmla="*/ 0 w 18288"/>
-              <a:gd name="connsiteY13" fmla="*/ 3773507 h 5590381"/>
-              <a:gd name="connsiteX14" fmla="*/ 0 w 18288"/>
-              <a:gd name="connsiteY14" fmla="*/ 3186517 h 5590381"/>
-              <a:gd name="connsiteX15" fmla="*/ 0 w 18288"/>
-              <a:gd name="connsiteY15" fmla="*/ 2487720 h 5590381"/>
-              <a:gd name="connsiteX16" fmla="*/ 0 w 18288"/>
-              <a:gd name="connsiteY16" fmla="*/ 1956633 h 5590381"/>
-              <a:gd name="connsiteX17" fmla="*/ 0 w 18288"/>
-              <a:gd name="connsiteY17" fmla="*/ 1425547 h 5590381"/>
-              <a:gd name="connsiteX18" fmla="*/ 0 w 18288"/>
-              <a:gd name="connsiteY18" fmla="*/ 614942 h 5590381"/>
-              <a:gd name="connsiteX19" fmla="*/ 0 w 18288"/>
-              <a:gd name="connsiteY19" fmla="*/ 0 h 5590381"/>
+              <a:gd name="csX0" fmla="*/ 0 w 18288"/>
+              <a:gd name="csY0" fmla="*/ 0 h 5590381"/>
+              <a:gd name="csX1" fmla="*/ 18288 w 18288"/>
+              <a:gd name="csY1" fmla="*/ 0 h 5590381"/>
+              <a:gd name="csX2" fmla="*/ 18288 w 18288"/>
+              <a:gd name="csY2" fmla="*/ 754701 h 5590381"/>
+              <a:gd name="csX3" fmla="*/ 18288 w 18288"/>
+              <a:gd name="csY3" fmla="*/ 1565307 h 5590381"/>
+              <a:gd name="csX4" fmla="*/ 18288 w 18288"/>
+              <a:gd name="csY4" fmla="*/ 2152297 h 5590381"/>
+              <a:gd name="csX5" fmla="*/ 18288 w 18288"/>
+              <a:gd name="csY5" fmla="*/ 2906998 h 5590381"/>
+              <a:gd name="csX6" fmla="*/ 18288 w 18288"/>
+              <a:gd name="csY6" fmla="*/ 3549892 h 5590381"/>
+              <a:gd name="csX7" fmla="*/ 18288 w 18288"/>
+              <a:gd name="csY7" fmla="*/ 4080978 h 5590381"/>
+              <a:gd name="csX8" fmla="*/ 18288 w 18288"/>
+              <a:gd name="csY8" fmla="*/ 4835680 h 5590381"/>
+              <a:gd name="csX9" fmla="*/ 18288 w 18288"/>
+              <a:gd name="csY9" fmla="*/ 5590381 h 5590381"/>
+              <a:gd name="csX10" fmla="*/ 0 w 18288"/>
+              <a:gd name="csY10" fmla="*/ 5590381 h 5590381"/>
+              <a:gd name="csX11" fmla="*/ 0 w 18288"/>
+              <a:gd name="csY11" fmla="*/ 4835680 h 5590381"/>
+              <a:gd name="csX12" fmla="*/ 0 w 18288"/>
+              <a:gd name="csY12" fmla="*/ 4304593 h 5590381"/>
+              <a:gd name="csX13" fmla="*/ 0 w 18288"/>
+              <a:gd name="csY13" fmla="*/ 3773507 h 5590381"/>
+              <a:gd name="csX14" fmla="*/ 0 w 18288"/>
+              <a:gd name="csY14" fmla="*/ 3186517 h 5590381"/>
+              <a:gd name="csX15" fmla="*/ 0 w 18288"/>
+              <a:gd name="csY15" fmla="*/ 2487720 h 5590381"/>
+              <a:gd name="csX16" fmla="*/ 0 w 18288"/>
+              <a:gd name="csY16" fmla="*/ 1956633 h 5590381"/>
+              <a:gd name="csX17" fmla="*/ 0 w 18288"/>
+              <a:gd name="csY17" fmla="*/ 1425547 h 5590381"/>
+              <a:gd name="csX18" fmla="*/ 0 w 18288"/>
+              <a:gd name="csY18" fmla="*/ 614942 h 5590381"/>
+              <a:gd name="csX19" fmla="*/ 0 w 18288"/>
+              <a:gd name="csY19" fmla="*/ 0 h 5590381"/>
             </a:gdLst>
             <a:ahLst/>
             <a:cxnLst>
               <a:cxn ang="0">
-                <a:pos x="connsiteX0" y="connsiteY0"/>
+                <a:pos x="csX0" y="csY0"/>
               </a:cxn>
               <a:cxn ang="0">
-                <a:pos x="connsiteX1" y="connsiteY1"/>
+                <a:pos x="csX1" y="csY1"/>
               </a:cxn>
               <a:cxn ang="0">
-                <a:pos x="connsiteX2" y="connsiteY2"/>
+                <a:pos x="csX2" y="csY2"/>
               </a:cxn>
               <a:cxn ang="0">
-                <a:pos x="connsiteX3" y="connsiteY3"/>
+                <a:pos x="csX3" y="csY3"/>
               </a:cxn>
               <a:cxn ang="0">
-                <a:pos x="connsiteX4" y="connsiteY4"/>
+                <a:pos x="csX4" y="csY4"/>
               </a:cxn>
               <a:cxn ang="0">
-                <a:pos x="connsiteX5" y="connsiteY5"/>
+                <a:pos x="csX5" y="csY5"/>
               </a:cxn>
               <a:cxn ang="0">
-                <a:pos x="connsiteX6" y="connsiteY6"/>
+                <a:pos x="csX6" y="csY6"/>
               </a:cxn>
               <a:cxn ang="0">
-                <a:pos x="connsiteX7" y="connsiteY7"/>
+                <a:pos x="csX7" y="csY7"/>
               </a:cxn>
               <a:cxn ang="0">
-                <a:pos x="connsiteX8" y="connsiteY8"/>
+                <a:pos x="csX8" y="csY8"/>
               </a:cxn>
               <a:cxn ang="0">
-                <a:pos x="connsiteX9" y="connsiteY9"/>
+                <a:pos x="csX9" y="csY9"/>
               </a:cxn>
               <a:cxn ang="0">
-                <a:pos x="connsiteX10" y="connsiteY10"/>
+                <a:pos x="csX10" y="csY10"/>
               </a:cxn>
               <a:cxn ang="0">
-                <a:pos x="connsiteX11" y="connsiteY11"/>
+                <a:pos x="csX11" y="csY11"/>
               </a:cxn>
               <a:cxn ang="0">
-                <a:pos x="connsiteX12" y="connsiteY12"/>
+                <a:pos x="csX12" y="csY12"/>
               </a:cxn>
               <a:cxn ang="0">
-                <a:pos x="connsiteX13" y="connsiteY13"/>
+                <a:pos x="csX13" y="csY13"/>
               </a:cxn>
               <a:cxn ang="0">
-                <a:pos x="connsiteX14" y="connsiteY14"/>
+                <a:pos x="csX14" y="csY14"/>
               </a:cxn>
               <a:cxn ang="0">
-                <a:pos x="connsiteX15" y="connsiteY15"/>
+                <a:pos x="csX15" y="csY15"/>
               </a:cxn>
               <a:cxn ang="0">
-                <a:pos x="connsiteX16" y="connsiteY16"/>
+                <a:pos x="csX16" y="csY16"/>
               </a:cxn>
               <a:cxn ang="0">
-                <a:pos x="connsiteX17" y="connsiteY17"/>
+                <a:pos x="csX17" y="csY17"/>
               </a:cxn>
               <a:cxn ang="0">
-                <a:pos x="connsiteX18" y="connsiteY18"/>
+                <a:pos x="csX18" y="csY18"/>
               </a:cxn>
               <a:cxn ang="0">
-                <a:pos x="connsiteX19" y="connsiteY19"/>
+                <a:pos x="csX19" y="csY19"/>
               </a:cxn>
             </a:cxnLst>
             <a:rect l="l" t="t" r="r" b="b"/>
@@ -20243,68 +20243,68 @@
           <a:custGeom>
             <a:avLst/>
             <a:gdLst>
-              <a:gd name="connsiteX0" fmla="*/ 0 w 3255095"/>
-              <a:gd name="connsiteY0" fmla="*/ 0 h 18288"/>
-              <a:gd name="connsiteX1" fmla="*/ 618468 w 3255095"/>
-              <a:gd name="connsiteY1" fmla="*/ 0 h 18288"/>
-              <a:gd name="connsiteX2" fmla="*/ 1269487 w 3255095"/>
-              <a:gd name="connsiteY2" fmla="*/ 0 h 18288"/>
-              <a:gd name="connsiteX3" fmla="*/ 1953057 w 3255095"/>
-              <a:gd name="connsiteY3" fmla="*/ 0 h 18288"/>
-              <a:gd name="connsiteX4" fmla="*/ 2636627 w 3255095"/>
-              <a:gd name="connsiteY4" fmla="*/ 0 h 18288"/>
-              <a:gd name="connsiteX5" fmla="*/ 3255095 w 3255095"/>
-              <a:gd name="connsiteY5" fmla="*/ 0 h 18288"/>
-              <a:gd name="connsiteX6" fmla="*/ 3255095 w 3255095"/>
-              <a:gd name="connsiteY6" fmla="*/ 18288 h 18288"/>
-              <a:gd name="connsiteX7" fmla="*/ 2538974 w 3255095"/>
-              <a:gd name="connsiteY7" fmla="*/ 18288 h 18288"/>
-              <a:gd name="connsiteX8" fmla="*/ 1822853 w 3255095"/>
-              <a:gd name="connsiteY8" fmla="*/ 18288 h 18288"/>
-              <a:gd name="connsiteX9" fmla="*/ 1171834 w 3255095"/>
-              <a:gd name="connsiteY9" fmla="*/ 18288 h 18288"/>
-              <a:gd name="connsiteX10" fmla="*/ 0 w 3255095"/>
-              <a:gd name="connsiteY10" fmla="*/ 18288 h 18288"/>
-              <a:gd name="connsiteX11" fmla="*/ 0 w 3255095"/>
-              <a:gd name="connsiteY11" fmla="*/ 0 h 18288"/>
+              <a:gd name="csX0" fmla="*/ 0 w 3255095"/>
+              <a:gd name="csY0" fmla="*/ 0 h 18288"/>
+              <a:gd name="csX1" fmla="*/ 618468 w 3255095"/>
+              <a:gd name="csY1" fmla="*/ 0 h 18288"/>
+              <a:gd name="csX2" fmla="*/ 1269487 w 3255095"/>
+              <a:gd name="csY2" fmla="*/ 0 h 18288"/>
+              <a:gd name="csX3" fmla="*/ 1953057 w 3255095"/>
+              <a:gd name="csY3" fmla="*/ 0 h 18288"/>
+              <a:gd name="csX4" fmla="*/ 2636627 w 3255095"/>
+              <a:gd name="csY4" fmla="*/ 0 h 18288"/>
+              <a:gd name="csX5" fmla="*/ 3255095 w 3255095"/>
+              <a:gd name="csY5" fmla="*/ 0 h 18288"/>
+              <a:gd name="csX6" fmla="*/ 3255095 w 3255095"/>
+              <a:gd name="csY6" fmla="*/ 18288 h 18288"/>
+              <a:gd name="csX7" fmla="*/ 2538974 w 3255095"/>
+              <a:gd name="csY7" fmla="*/ 18288 h 18288"/>
+              <a:gd name="csX8" fmla="*/ 1822853 w 3255095"/>
+              <a:gd name="csY8" fmla="*/ 18288 h 18288"/>
+              <a:gd name="csX9" fmla="*/ 1171834 w 3255095"/>
+              <a:gd name="csY9" fmla="*/ 18288 h 18288"/>
+              <a:gd name="csX10" fmla="*/ 0 w 3255095"/>
+              <a:gd name="csY10" fmla="*/ 18288 h 18288"/>
+              <a:gd name="csX11" fmla="*/ 0 w 3255095"/>
+              <a:gd name="csY11" fmla="*/ 0 h 18288"/>
             </a:gdLst>
             <a:ahLst/>
             <a:cxnLst>
               <a:cxn ang="0">
-                <a:pos x="connsiteX0" y="connsiteY0"/>
+                <a:pos x="csX0" y="csY0"/>
               </a:cxn>
               <a:cxn ang="0">
-                <a:pos x="connsiteX1" y="connsiteY1"/>
+                <a:pos x="csX1" y="csY1"/>
               </a:cxn>
               <a:cxn ang="0">
-                <a:pos x="connsiteX2" y="connsiteY2"/>
+                <a:pos x="csX2" y="csY2"/>
               </a:cxn>
               <a:cxn ang="0">
-                <a:pos x="connsiteX3" y="connsiteY3"/>
+                <a:pos x="csX3" y="csY3"/>
               </a:cxn>
               <a:cxn ang="0">
-                <a:pos x="connsiteX4" y="connsiteY4"/>
+                <a:pos x="csX4" y="csY4"/>
               </a:cxn>
               <a:cxn ang="0">
-                <a:pos x="connsiteX5" y="connsiteY5"/>
+                <a:pos x="csX5" y="csY5"/>
               </a:cxn>
               <a:cxn ang="0">
-                <a:pos x="connsiteX6" y="connsiteY6"/>
+                <a:pos x="csX6" y="csY6"/>
               </a:cxn>
               <a:cxn ang="0">
-                <a:pos x="connsiteX7" y="connsiteY7"/>
+                <a:pos x="csX7" y="csY7"/>
               </a:cxn>
               <a:cxn ang="0">
-                <a:pos x="connsiteX8" y="connsiteY8"/>
+                <a:pos x="csX8" y="csY8"/>
               </a:cxn>
               <a:cxn ang="0">
-                <a:pos x="connsiteX9" y="connsiteY9"/>
+                <a:pos x="csX9" y="csY9"/>
               </a:cxn>
               <a:cxn ang="0">
-                <a:pos x="connsiteX10" y="connsiteY10"/>
+                <a:pos x="csX10" y="csY10"/>
               </a:cxn>
               <a:cxn ang="0">
-                <a:pos x="connsiteX11" y="connsiteY11"/>
+                <a:pos x="csX11" y="csY11"/>
               </a:cxn>
             </a:cxnLst>
             <a:rect l="l" t="t" r="r" b="b"/>
@@ -21239,68 +21239,68 @@
           <a:custGeom>
             <a:avLst/>
             <a:gdLst>
-              <a:gd name="connsiteX0" fmla="*/ 0 w 3255095"/>
-              <a:gd name="connsiteY0" fmla="*/ 0 h 18288"/>
-              <a:gd name="connsiteX1" fmla="*/ 618468 w 3255095"/>
-              <a:gd name="connsiteY1" fmla="*/ 0 h 18288"/>
-              <a:gd name="connsiteX2" fmla="*/ 1269487 w 3255095"/>
-              <a:gd name="connsiteY2" fmla="*/ 0 h 18288"/>
-              <a:gd name="connsiteX3" fmla="*/ 1953057 w 3255095"/>
-              <a:gd name="connsiteY3" fmla="*/ 0 h 18288"/>
-              <a:gd name="connsiteX4" fmla="*/ 2636627 w 3255095"/>
-              <a:gd name="connsiteY4" fmla="*/ 0 h 18288"/>
-              <a:gd name="connsiteX5" fmla="*/ 3255095 w 3255095"/>
-              <a:gd name="connsiteY5" fmla="*/ 0 h 18288"/>
-              <a:gd name="connsiteX6" fmla="*/ 3255095 w 3255095"/>
-              <a:gd name="connsiteY6" fmla="*/ 18288 h 18288"/>
-              <a:gd name="connsiteX7" fmla="*/ 2538974 w 3255095"/>
-              <a:gd name="connsiteY7" fmla="*/ 18288 h 18288"/>
-              <a:gd name="connsiteX8" fmla="*/ 1822853 w 3255095"/>
-              <a:gd name="connsiteY8" fmla="*/ 18288 h 18288"/>
-              <a:gd name="connsiteX9" fmla="*/ 1171834 w 3255095"/>
-              <a:gd name="connsiteY9" fmla="*/ 18288 h 18288"/>
-              <a:gd name="connsiteX10" fmla="*/ 0 w 3255095"/>
-              <a:gd name="connsiteY10" fmla="*/ 18288 h 18288"/>
-              <a:gd name="connsiteX11" fmla="*/ 0 w 3255095"/>
-              <a:gd name="connsiteY11" fmla="*/ 0 h 18288"/>
+              <a:gd name="csX0" fmla="*/ 0 w 3255095"/>
+              <a:gd name="csY0" fmla="*/ 0 h 18288"/>
+              <a:gd name="csX1" fmla="*/ 618468 w 3255095"/>
+              <a:gd name="csY1" fmla="*/ 0 h 18288"/>
+              <a:gd name="csX2" fmla="*/ 1269487 w 3255095"/>
+              <a:gd name="csY2" fmla="*/ 0 h 18288"/>
+              <a:gd name="csX3" fmla="*/ 1953057 w 3255095"/>
+              <a:gd name="csY3" fmla="*/ 0 h 18288"/>
+              <a:gd name="csX4" fmla="*/ 2636627 w 3255095"/>
+              <a:gd name="csY4" fmla="*/ 0 h 18288"/>
+              <a:gd name="csX5" fmla="*/ 3255095 w 3255095"/>
+              <a:gd name="csY5" fmla="*/ 0 h 18288"/>
+              <a:gd name="csX6" fmla="*/ 3255095 w 3255095"/>
+              <a:gd name="csY6" fmla="*/ 18288 h 18288"/>
+              <a:gd name="csX7" fmla="*/ 2538974 w 3255095"/>
+              <a:gd name="csY7" fmla="*/ 18288 h 18288"/>
+              <a:gd name="csX8" fmla="*/ 1822853 w 3255095"/>
+              <a:gd name="csY8" fmla="*/ 18288 h 18288"/>
+              <a:gd name="csX9" fmla="*/ 1171834 w 3255095"/>
+              <a:gd name="csY9" fmla="*/ 18288 h 18288"/>
+              <a:gd name="csX10" fmla="*/ 0 w 3255095"/>
+              <a:gd name="csY10" fmla="*/ 18288 h 18288"/>
+              <a:gd name="csX11" fmla="*/ 0 w 3255095"/>
+              <a:gd name="csY11" fmla="*/ 0 h 18288"/>
             </a:gdLst>
             <a:ahLst/>
             <a:cxnLst>
               <a:cxn ang="0">
-                <a:pos x="connsiteX0" y="connsiteY0"/>
+                <a:pos x="csX0" y="csY0"/>
               </a:cxn>
               <a:cxn ang="0">
-                <a:pos x="connsiteX1" y="connsiteY1"/>
+                <a:pos x="csX1" y="csY1"/>
               </a:cxn>
               <a:cxn ang="0">
-                <a:pos x="connsiteX2" y="connsiteY2"/>
+                <a:pos x="csX2" y="csY2"/>
               </a:cxn>
               <a:cxn ang="0">
-                <a:pos x="connsiteX3" y="connsiteY3"/>
+                <a:pos x="csX3" y="csY3"/>
               </a:cxn>
               <a:cxn ang="0">
-                <a:pos x="connsiteX4" y="connsiteY4"/>
+                <a:pos x="csX4" y="csY4"/>
               </a:cxn>
               <a:cxn ang="0">
-                <a:pos x="connsiteX5" y="connsiteY5"/>
+                <a:pos x="csX5" y="csY5"/>
               </a:cxn>
               <a:cxn ang="0">
-                <a:pos x="connsiteX6" y="connsiteY6"/>
+                <a:pos x="csX6" y="csY6"/>
               </a:cxn>
               <a:cxn ang="0">
-                <a:pos x="connsiteX7" y="connsiteY7"/>
+                <a:pos x="csX7" y="csY7"/>
               </a:cxn>
               <a:cxn ang="0">
-                <a:pos x="connsiteX8" y="connsiteY8"/>
+                <a:pos x="csX8" y="csY8"/>
               </a:cxn>
               <a:cxn ang="0">
-                <a:pos x="connsiteX9" y="connsiteY9"/>
+                <a:pos x="csX9" y="csY9"/>
               </a:cxn>
               <a:cxn ang="0">
-                <a:pos x="connsiteX10" y="connsiteY10"/>
+                <a:pos x="csX10" y="csY10"/>
               </a:cxn>
               <a:cxn ang="0">
-                <a:pos x="connsiteX11" y="connsiteY11"/>
+                <a:pos x="csX11" y="csY11"/>
               </a:cxn>
             </a:cxnLst>
             <a:rect l="l" t="t" r="r" b="b"/>
@@ -21948,68 +21948,68 @@
           <a:custGeom>
             <a:avLst/>
             <a:gdLst>
-              <a:gd name="connsiteX0" fmla="*/ 0 w 3255095"/>
-              <a:gd name="connsiteY0" fmla="*/ 0 h 18288"/>
-              <a:gd name="connsiteX1" fmla="*/ 618468 w 3255095"/>
-              <a:gd name="connsiteY1" fmla="*/ 0 h 18288"/>
-              <a:gd name="connsiteX2" fmla="*/ 1269487 w 3255095"/>
-              <a:gd name="connsiteY2" fmla="*/ 0 h 18288"/>
-              <a:gd name="connsiteX3" fmla="*/ 1953057 w 3255095"/>
-              <a:gd name="connsiteY3" fmla="*/ 0 h 18288"/>
-              <a:gd name="connsiteX4" fmla="*/ 2636627 w 3255095"/>
-              <a:gd name="connsiteY4" fmla="*/ 0 h 18288"/>
-              <a:gd name="connsiteX5" fmla="*/ 3255095 w 3255095"/>
-              <a:gd name="connsiteY5" fmla="*/ 0 h 18288"/>
-              <a:gd name="connsiteX6" fmla="*/ 3255095 w 3255095"/>
-              <a:gd name="connsiteY6" fmla="*/ 18288 h 18288"/>
-              <a:gd name="connsiteX7" fmla="*/ 2538974 w 3255095"/>
-              <a:gd name="connsiteY7" fmla="*/ 18288 h 18288"/>
-              <a:gd name="connsiteX8" fmla="*/ 1822853 w 3255095"/>
-              <a:gd name="connsiteY8" fmla="*/ 18288 h 18288"/>
-              <a:gd name="connsiteX9" fmla="*/ 1171834 w 3255095"/>
-              <a:gd name="connsiteY9" fmla="*/ 18288 h 18288"/>
-              <a:gd name="connsiteX10" fmla="*/ 0 w 3255095"/>
-              <a:gd name="connsiteY10" fmla="*/ 18288 h 18288"/>
-              <a:gd name="connsiteX11" fmla="*/ 0 w 3255095"/>
-              <a:gd name="connsiteY11" fmla="*/ 0 h 18288"/>
+              <a:gd name="csX0" fmla="*/ 0 w 3255095"/>
+              <a:gd name="csY0" fmla="*/ 0 h 18288"/>
+              <a:gd name="csX1" fmla="*/ 618468 w 3255095"/>
+              <a:gd name="csY1" fmla="*/ 0 h 18288"/>
+              <a:gd name="csX2" fmla="*/ 1269487 w 3255095"/>
+              <a:gd name="csY2" fmla="*/ 0 h 18288"/>
+              <a:gd name="csX3" fmla="*/ 1953057 w 3255095"/>
+              <a:gd name="csY3" fmla="*/ 0 h 18288"/>
+              <a:gd name="csX4" fmla="*/ 2636627 w 3255095"/>
+              <a:gd name="csY4" fmla="*/ 0 h 18288"/>
+              <a:gd name="csX5" fmla="*/ 3255095 w 3255095"/>
+              <a:gd name="csY5" fmla="*/ 0 h 18288"/>
+              <a:gd name="csX6" fmla="*/ 3255095 w 3255095"/>
+              <a:gd name="csY6" fmla="*/ 18288 h 18288"/>
+              <a:gd name="csX7" fmla="*/ 2538974 w 3255095"/>
+              <a:gd name="csY7" fmla="*/ 18288 h 18288"/>
+              <a:gd name="csX8" fmla="*/ 1822853 w 3255095"/>
+              <a:gd name="csY8" fmla="*/ 18288 h 18288"/>
+              <a:gd name="csX9" fmla="*/ 1171834 w 3255095"/>
+              <a:gd name="csY9" fmla="*/ 18288 h 18288"/>
+              <a:gd name="csX10" fmla="*/ 0 w 3255095"/>
+              <a:gd name="csY10" fmla="*/ 18288 h 18288"/>
+              <a:gd name="csX11" fmla="*/ 0 w 3255095"/>
+              <a:gd name="csY11" fmla="*/ 0 h 18288"/>
             </a:gdLst>
             <a:ahLst/>
             <a:cxnLst>
               <a:cxn ang="0">
-                <a:pos x="connsiteX0" y="connsiteY0"/>
+                <a:pos x="csX0" y="csY0"/>
               </a:cxn>
               <a:cxn ang="0">
-                <a:pos x="connsiteX1" y="connsiteY1"/>
+                <a:pos x="csX1" y="csY1"/>
               </a:cxn>
               <a:cxn ang="0">
-                <a:pos x="connsiteX2" y="connsiteY2"/>
+                <a:pos x="csX2" y="csY2"/>
               </a:cxn>
               <a:cxn ang="0">
-                <a:pos x="connsiteX3" y="connsiteY3"/>
+                <a:pos x="csX3" y="csY3"/>
               </a:cxn>
               <a:cxn ang="0">
-                <a:pos x="connsiteX4" y="connsiteY4"/>
+                <a:pos x="csX4" y="csY4"/>
               </a:cxn>
               <a:cxn ang="0">
-                <a:pos x="connsiteX5" y="connsiteY5"/>
+                <a:pos x="csX5" y="csY5"/>
               </a:cxn>
               <a:cxn ang="0">
-                <a:pos x="connsiteX6" y="connsiteY6"/>
+                <a:pos x="csX6" y="csY6"/>
               </a:cxn>
               <a:cxn ang="0">
-                <a:pos x="connsiteX7" y="connsiteY7"/>
+                <a:pos x="csX7" y="csY7"/>
               </a:cxn>
               <a:cxn ang="0">
-                <a:pos x="connsiteX8" y="connsiteY8"/>
+                <a:pos x="csX8" y="csY8"/>
               </a:cxn>
               <a:cxn ang="0">
-                <a:pos x="connsiteX9" y="connsiteY9"/>
+                <a:pos x="csX9" y="csY9"/>
               </a:cxn>
               <a:cxn ang="0">
-                <a:pos x="connsiteX10" y="connsiteY10"/>
+                <a:pos x="csX10" y="csY10"/>
               </a:cxn>
               <a:cxn ang="0">
-                <a:pos x="connsiteX11" y="connsiteY11"/>
+                <a:pos x="csX11" y="csY11"/>
               </a:cxn>
             </a:cxnLst>
             <a:rect l="l" t="t" r="r" b="b"/>
@@ -25987,93 +25987,93 @@
           <a:custGeom>
             <a:avLst/>
             <a:gdLst>
-              <a:gd name="connsiteX0" fmla="*/ 0 w 4243589"/>
-              <a:gd name="connsiteY0" fmla="*/ 0 h 18288"/>
-              <a:gd name="connsiteX1" fmla="*/ 478919 w 4243589"/>
-              <a:gd name="connsiteY1" fmla="*/ 0 h 18288"/>
-              <a:gd name="connsiteX2" fmla="*/ 957839 w 4243589"/>
-              <a:gd name="connsiteY2" fmla="*/ 0 h 18288"/>
-              <a:gd name="connsiteX3" fmla="*/ 1521630 w 4243589"/>
-              <a:gd name="connsiteY3" fmla="*/ 0 h 18288"/>
-              <a:gd name="connsiteX4" fmla="*/ 2212729 w 4243589"/>
-              <a:gd name="connsiteY4" fmla="*/ 0 h 18288"/>
-              <a:gd name="connsiteX5" fmla="*/ 2734084 w 4243589"/>
-              <a:gd name="connsiteY5" fmla="*/ 0 h 18288"/>
-              <a:gd name="connsiteX6" fmla="*/ 3255439 w 4243589"/>
-              <a:gd name="connsiteY6" fmla="*/ 0 h 18288"/>
-              <a:gd name="connsiteX7" fmla="*/ 4243589 w 4243589"/>
-              <a:gd name="connsiteY7" fmla="*/ 0 h 18288"/>
-              <a:gd name="connsiteX8" fmla="*/ 4243589 w 4243589"/>
-              <a:gd name="connsiteY8" fmla="*/ 18288 h 18288"/>
-              <a:gd name="connsiteX9" fmla="*/ 3594926 w 4243589"/>
-              <a:gd name="connsiteY9" fmla="*/ 18288 h 18288"/>
-              <a:gd name="connsiteX10" fmla="*/ 3073571 w 4243589"/>
-              <a:gd name="connsiteY10" fmla="*/ 18288 h 18288"/>
-              <a:gd name="connsiteX11" fmla="*/ 2552216 w 4243589"/>
-              <a:gd name="connsiteY11" fmla="*/ 18288 h 18288"/>
-              <a:gd name="connsiteX12" fmla="*/ 1903553 w 4243589"/>
-              <a:gd name="connsiteY12" fmla="*/ 18288 h 18288"/>
-              <a:gd name="connsiteX13" fmla="*/ 1212454 w 4243589"/>
-              <a:gd name="connsiteY13" fmla="*/ 18288 h 18288"/>
-              <a:gd name="connsiteX14" fmla="*/ 733535 w 4243589"/>
-              <a:gd name="connsiteY14" fmla="*/ 18288 h 18288"/>
-              <a:gd name="connsiteX15" fmla="*/ 0 w 4243589"/>
-              <a:gd name="connsiteY15" fmla="*/ 18288 h 18288"/>
-              <a:gd name="connsiteX16" fmla="*/ 0 w 4243589"/>
-              <a:gd name="connsiteY16" fmla="*/ 0 h 18288"/>
+              <a:gd name="csX0" fmla="*/ 0 w 4243589"/>
+              <a:gd name="csY0" fmla="*/ 0 h 18288"/>
+              <a:gd name="csX1" fmla="*/ 478919 w 4243589"/>
+              <a:gd name="csY1" fmla="*/ 0 h 18288"/>
+              <a:gd name="csX2" fmla="*/ 957839 w 4243589"/>
+              <a:gd name="csY2" fmla="*/ 0 h 18288"/>
+              <a:gd name="csX3" fmla="*/ 1521630 w 4243589"/>
+              <a:gd name="csY3" fmla="*/ 0 h 18288"/>
+              <a:gd name="csX4" fmla="*/ 2212729 w 4243589"/>
+              <a:gd name="csY4" fmla="*/ 0 h 18288"/>
+              <a:gd name="csX5" fmla="*/ 2734084 w 4243589"/>
+              <a:gd name="csY5" fmla="*/ 0 h 18288"/>
+              <a:gd name="csX6" fmla="*/ 3255439 w 4243589"/>
+              <a:gd name="csY6" fmla="*/ 0 h 18288"/>
+              <a:gd name="csX7" fmla="*/ 4243589 w 4243589"/>
+              <a:gd name="csY7" fmla="*/ 0 h 18288"/>
+              <a:gd name="csX8" fmla="*/ 4243589 w 4243589"/>
+              <a:gd name="csY8" fmla="*/ 18288 h 18288"/>
+              <a:gd name="csX9" fmla="*/ 3594926 w 4243589"/>
+              <a:gd name="csY9" fmla="*/ 18288 h 18288"/>
+              <a:gd name="csX10" fmla="*/ 3073571 w 4243589"/>
+              <a:gd name="csY10" fmla="*/ 18288 h 18288"/>
+              <a:gd name="csX11" fmla="*/ 2552216 w 4243589"/>
+              <a:gd name="csY11" fmla="*/ 18288 h 18288"/>
+              <a:gd name="csX12" fmla="*/ 1903553 w 4243589"/>
+              <a:gd name="csY12" fmla="*/ 18288 h 18288"/>
+              <a:gd name="csX13" fmla="*/ 1212454 w 4243589"/>
+              <a:gd name="csY13" fmla="*/ 18288 h 18288"/>
+              <a:gd name="csX14" fmla="*/ 733535 w 4243589"/>
+              <a:gd name="csY14" fmla="*/ 18288 h 18288"/>
+              <a:gd name="csX15" fmla="*/ 0 w 4243589"/>
+              <a:gd name="csY15" fmla="*/ 18288 h 18288"/>
+              <a:gd name="csX16" fmla="*/ 0 w 4243589"/>
+              <a:gd name="csY16" fmla="*/ 0 h 18288"/>
             </a:gdLst>
             <a:ahLst/>
             <a:cxnLst>
               <a:cxn ang="0">
-                <a:pos x="connsiteX0" y="connsiteY0"/>
+                <a:pos x="csX0" y="csY0"/>
               </a:cxn>
               <a:cxn ang="0">
-                <a:pos x="connsiteX1" y="connsiteY1"/>
+                <a:pos x="csX1" y="csY1"/>
               </a:cxn>
               <a:cxn ang="0">
-                <a:pos x="connsiteX2" y="connsiteY2"/>
+                <a:pos x="csX2" y="csY2"/>
               </a:cxn>
               <a:cxn ang="0">
-                <a:pos x="connsiteX3" y="connsiteY3"/>
+                <a:pos x="csX3" y="csY3"/>
               </a:cxn>
               <a:cxn ang="0">
-                <a:pos x="connsiteX4" y="connsiteY4"/>
+                <a:pos x="csX4" y="csY4"/>
               </a:cxn>
               <a:cxn ang="0">
-                <a:pos x="connsiteX5" y="connsiteY5"/>
+                <a:pos x="csX5" y="csY5"/>
               </a:cxn>
               <a:cxn ang="0">
-                <a:pos x="connsiteX6" y="connsiteY6"/>
+                <a:pos x="csX6" y="csY6"/>
               </a:cxn>
               <a:cxn ang="0">
-                <a:pos x="connsiteX7" y="connsiteY7"/>
+                <a:pos x="csX7" y="csY7"/>
               </a:cxn>
               <a:cxn ang="0">
-                <a:pos x="connsiteX8" y="connsiteY8"/>
+                <a:pos x="csX8" y="csY8"/>
               </a:cxn>
               <a:cxn ang="0">
-                <a:pos x="connsiteX9" y="connsiteY9"/>
+                <a:pos x="csX9" y="csY9"/>
               </a:cxn>
               <a:cxn ang="0">
-                <a:pos x="connsiteX10" y="connsiteY10"/>
+                <a:pos x="csX10" y="csY10"/>
               </a:cxn>
               <a:cxn ang="0">
-                <a:pos x="connsiteX11" y="connsiteY11"/>
+                <a:pos x="csX11" y="csY11"/>
               </a:cxn>
               <a:cxn ang="0">
-                <a:pos x="connsiteX12" y="connsiteY12"/>
+                <a:pos x="csX12" y="csY12"/>
               </a:cxn>
               <a:cxn ang="0">
-                <a:pos x="connsiteX13" y="connsiteY13"/>
+                <a:pos x="csX13" y="csY13"/>
               </a:cxn>
               <a:cxn ang="0">
-                <a:pos x="connsiteX14" y="connsiteY14"/>
+                <a:pos x="csX14" y="csY14"/>
               </a:cxn>
               <a:cxn ang="0">
-                <a:pos x="connsiteX15" y="connsiteY15"/>
+                <a:pos x="csX15" y="csY15"/>
               </a:cxn>
               <a:cxn ang="0">
-                <a:pos x="connsiteX16" y="connsiteY16"/>
+                <a:pos x="csX16" y="csY16"/>
               </a:cxn>
             </a:cxnLst>
             <a:rect l="l" t="t" r="r" b="b"/>

</xml_diff>